<commit_message>
docs(presentation): diapositive tontine a lot, lots partages, versements et departs (v1.6)
</commit_message>
<xml_diff>
--- a/tontinepro-frontend/public/docs/TontinePro-Presentation.pptx
+++ b/tontinepro-frontend/public/docs/TontinePro-Presentation.pptx
@@ -13,9 +13,10 @@
     <p:sldId id="261" r:id="rId7"/>
     <p:sldId id="262" r:id="rId8"/>
     <p:sldId id="263" r:id="rId9"/>
+    <p:sldId id="264" r:id="rId10"/>
   </p:sldIdLst>
   <p:notesMasterIdLst>
-    <p:notesMasterId r:id="rId10"/>
+    <p:notesMasterId r:id="rId11"/>
   </p:notesMasterIdLst>
   <p:sldSz cx="12192000" cy="6858000"/>
   <p:notesSz cx="6858000" cy="12192000"/>
@@ -1149,6 +1150,94 @@
             <a:fld id="{F7021451-1387-4CA6-816F-3879F97B5CBC}" type="slidenum">
               <a:rPr lang="en-US"/>
               <a:t>8</a:t>
+            </a:fld>
+            <a:endParaRPr lang="en-US"/>
+          </a:p>
+        </p:txBody>
+      </p:sp>
+    </p:spTree>
+    <p:extLst>
+      <p:ext uri="{BB962C8B-B14F-4D97-AF65-F5344CB8AC3E}">
+        <p14:creationId xmlns:p14="http://schemas.microsoft.com/office/powerpoint/2010/main" val="1024086991"/>
+      </p:ext>
+    </p:extLst>
+  </p:cSld>
+  <p:clrMapOvr>
+    <a:masterClrMapping/>
+  </p:clrMapOvr>
+</p:notes>
+</file>
+
+<file path=ppt/notesSlides/notesSlide9.xml><?xml version="1.0" encoding="utf-8"?>
+<p:notes xmlns:a="http://schemas.openxmlformats.org/drawingml/2006/main" xmlns:r="http://schemas.openxmlformats.org/officeDocument/2006/relationships" xmlns:p="http://schemas.openxmlformats.org/presentationml/2006/main">
+  <p:cSld>
+    <p:spTree>
+      <p:nvGrpSpPr>
+        <p:cNvPr id="1" name=""/>
+        <p:cNvGrpSpPr/>
+        <p:nvPr/>
+      </p:nvGrpSpPr>
+      <p:grpSpPr>
+        <a:xfrm>
+          <a:off x="0" y="0"/>
+          <a:ext cx="0" cy="0"/>
+          <a:chOff x="0" y="0"/>
+          <a:chExt cx="0" cy="0"/>
+        </a:xfrm>
+      </p:grpSpPr>
+      <p:sp>
+        <p:nvSpPr>
+          <p:cNvPr id="2" name="Slide Image Placeholder 1"/>
+          <p:cNvSpPr>
+            <a:spLocks noGrp="1" noRot="1" noChangeAspect="1"/>
+          </p:cNvSpPr>
+          <p:nvPr>
+            <p:ph type="sldImg"/>
+          </p:nvPr>
+        </p:nvSpPr>
+        <p:spPr/>
+      </p:sp>
+      <p:sp>
+        <p:nvSpPr>
+          <p:cNvPr id="3" name="Notes Placeholder 2"/>
+          <p:cNvSpPr>
+            <a:spLocks noGrp="1"/>
+          </p:cNvSpPr>
+          <p:nvPr>
+            <p:ph type="body" idx="1"/>
+          </p:nvPr>
+        </p:nvSpPr>
+        <p:spPr/>
+        <p:txBody>
+          <a:bodyPr/>
+          <a:lstStyle/>
+          <a:p>
+            <a:r>
+              <a:rPr lang="en-US" dirty="0"/>
+              <a:t/>
+            </a:r>
+            <a:endParaRPr lang="en-US" dirty="0"/>
+          </a:p>
+        </p:txBody>
+      </p:sp>
+      <p:sp>
+        <p:nvSpPr>
+          <p:cNvPr id="4" name="Slide Number Placeholder 3"/>
+          <p:cNvSpPr>
+            <a:spLocks noGrp="1"/>
+          </p:cNvSpPr>
+          <p:nvPr>
+            <p:ph type="sldNum" sz="quarter" idx="10"/>
+          </p:nvPr>
+        </p:nvSpPr>
+        <p:spPr/>
+        <p:txBody>
+          <a:bodyPr/>
+          <a:lstStyle/>
+          <a:p>
+            <a:fld id="{F7021451-1387-4CA6-816F-3879F97B5CBC}" type="slidenum">
+              <a:rPr lang="en-US"/>
+              <a:t>9</a:t>
             </a:fld>
             <a:endParaRPr lang="en-US"/>
           </a:p>
@@ -1675,7 +1764,7 @@
                   <a:srgbClr val="818CF8"/>
                 </a:solidFill>
               </a:rPr>
-              <a:t>Version 1.1  ·  Août 2026  ·  JumpyTech</a:t>
+              <a:t>Version 1.6  ·  Octobre 2026  ·  JumpyTech</a:t>
             </a:r>
             <a:endParaRPr lang="en-US" sz="1300" dirty="0"/>
           </a:p>
@@ -2405,7 +2494,7 @@
                   <a:srgbClr val="94A3B8"/>
                 </a:solidFill>
               </a:rPr>
-              <a:t>TontinePro v1.1  ·  JumpyTech  ·  © 2026</a:t>
+              <a:t>TontinePro v1.6  ·  JumpyTech  ·  © 2026</a:t>
             </a:r>
             <a:endParaRPr lang="en-US" sz="800" dirty="0"/>
           </a:p>
@@ -4141,7 +4230,7 @@
                   <a:srgbClr val="64748B"/>
                 </a:solidFill>
               </a:rPr>
-              <a:t>Cagnotte, lots partageables, figeage automatique</a:t>
+              <a:t>Lots partagés, versement par part, départs gérés</a:t>
             </a:r>
             <a:endParaRPr lang="en-US" sz="900" dirty="0"/>
           </a:p>
@@ -4177,7 +4266,7 @@
                   <a:srgbClr val="94A3B8"/>
                 </a:solidFill>
               </a:rPr>
-              <a:t>TontinePro v1.1  ·  JumpyTech  ·  © 2026</a:t>
+              <a:t>TontinePro v1.6  ·  JumpyTech  ·  © 2026</a:t>
             </a:r>
             <a:endParaRPr lang="en-US" sz="800" dirty="0"/>
           </a:p>
@@ -5151,7 +5240,7 @@
                   <a:srgbClr val="94A3B8"/>
                 </a:solidFill>
               </a:rPr>
-              <a:t>TontinePro v1.1  ·  JumpyTech  ·  © 2026</a:t>
+              <a:t>TontinePro v1.6  ·  JumpyTech  ·  © 2026</a:t>
             </a:r>
             <a:endParaRPr lang="en-US" sz="800" dirty="0"/>
           </a:p>
@@ -6197,7 +6286,7 @@
                   <a:srgbClr val="94A3B8"/>
                 </a:solidFill>
               </a:rPr>
-              <a:t>TontinePro v1.1  ·  JumpyTech  ·  © 2026</a:t>
+              <a:t>TontinePro v1.6  ·  JumpyTech  ·  © 2026</a:t>
             </a:r>
             <a:endParaRPr lang="en-US" sz="800" dirty="0"/>
           </a:p>
@@ -7243,7 +7332,7 @@
                   <a:srgbClr val="94A3B8"/>
                 </a:solidFill>
               </a:rPr>
-              <a:t>TontinePro v1.1  ·  JumpyTech  ·  © 2026</a:t>
+              <a:t>TontinePro v1.6  ·  JumpyTech  ·  © 2026</a:t>
             </a:r>
             <a:endParaRPr lang="en-US" sz="800" dirty="0"/>
           </a:p>
@@ -7296,6 +7385,1052 @@
 <file path=ppt/slides/slide7.xml><?xml version="1.0" encoding="utf-8"?>
 <p:sld xmlns:a="http://schemas.openxmlformats.org/drawingml/2006/main" xmlns:r="http://schemas.openxmlformats.org/officeDocument/2006/relationships" xmlns:p="http://schemas.openxmlformats.org/presentationml/2006/main">
   <p:cSld name="Slide 7">
+    <p:bg>
+      <p:bgPr>
+        <a:solidFill>
+          <a:srgbClr val="F8FAFC"/>
+        </a:solidFill>
+      </p:bgPr>
+    </p:bg>
+    <p:spTree>
+      <p:nvGrpSpPr>
+        <p:cNvPr id="1" name=""/>
+        <p:cNvGrpSpPr/>
+        <p:nvPr/>
+      </p:nvGrpSpPr>
+      <p:grpSpPr>
+        <a:xfrm>
+          <a:off x="0" y="0"/>
+          <a:ext cx="0" cy="0"/>
+          <a:chOff x="0" y="0"/>
+          <a:chExt cx="0" cy="0"/>
+        </a:xfrm>
+      </p:grpSpPr>
+      <p:sp>
+        <p:nvSpPr>
+          <p:cNvPr id="2" name="Text 0"/>
+          <p:cNvSpPr/>
+          <p:nvPr/>
+        </p:nvSpPr>
+        <p:spPr>
+          <a:xfrm>
+            <a:off x="457200" y="182880"/>
+            <a:ext cx="10972800" cy="365760"/>
+          </a:xfrm>
+          <a:prstGeom prst="rect">
+            <a:avLst/>
+          </a:prstGeom>
+          <a:noFill/>
+          <a:ln/>
+        </p:spPr>
+        <p:txBody>
+          <a:bodyPr wrap="square" rtlCol="0" anchor="ctr"/>
+          <a:lstStyle/>
+          <a:p>
+            <a:pPr indent="0" marL="0">
+              <a:buNone/>
+            </a:pPr>
+            <a:r>
+              <a:rPr lang="en-US" sz="1100" b="1" spc="300" kern="0" dirty="0">
+                <a:solidFill>
+                  <a:srgbClr val="4F46E5"/>
+                </a:solidFill>
+              </a:rPr>
+              <a:t>TONTINE À LOT</a:t>
+            </a:r>
+            <a:endParaRPr lang="en-US" sz="1100" dirty="0"/>
+          </a:p>
+        </p:txBody>
+      </p:sp>
+      <p:sp>
+        <p:nvSpPr>
+          <p:cNvPr id="3" name="Text 1"/>
+          <p:cNvSpPr/>
+          <p:nvPr/>
+        </p:nvSpPr>
+        <p:spPr>
+          <a:xfrm>
+            <a:off x="457200" y="548640"/>
+            <a:ext cx="10972800" cy="457200"/>
+          </a:xfrm>
+          <a:prstGeom prst="rect">
+            <a:avLst/>
+          </a:prstGeom>
+          <a:noFill/>
+          <a:ln/>
+        </p:spPr>
+        <p:txBody>
+          <a:bodyPr wrap="square" rtlCol="0" anchor="ctr"/>
+          <a:lstStyle/>
+          <a:p>
+            <a:pPr indent="0" marL="0">
+              <a:buNone/>
+            </a:pPr>
+            <a:r>
+              <a:rPr lang="en-US" sz="2200" b="1" dirty="0">
+                <a:solidFill>
+                  <a:srgbClr val="1E293B"/>
+                </a:solidFill>
+              </a:rPr>
+              <a:t>Un lot, plusieurs bénéficiaires — chacun reçoit sa juste part</a:t>
+            </a:r>
+            <a:endParaRPr lang="en-US" sz="2200" dirty="0"/>
+          </a:p>
+        </p:txBody>
+      </p:sp>
+      <p:sp>
+        <p:nvSpPr>
+          <p:cNvPr id="4" name="Shape 2"/>
+          <p:cNvSpPr/>
+          <p:nvPr/>
+        </p:nvSpPr>
+        <p:spPr>
+          <a:xfrm>
+            <a:off x="274320" y="1188720"/>
+            <a:ext cx="6858000" cy="4846320"/>
+          </a:xfrm>
+          <a:prstGeom prst="roundRect">
+            <a:avLst/>
+          </a:prstGeom>
+          <a:solidFill>
+            <a:srgbClr val="FFFFFF"/>
+          </a:solidFill>
+          <a:ln w="12700">
+            <a:solidFill>
+              <a:srgbClr val="E2E8F0"/>
+            </a:solidFill>
+            <a:prstDash val="solid"/>
+          </a:ln>
+        </p:spPr>
+      </p:sp>
+      <p:sp>
+        <p:nvSpPr>
+          <p:cNvPr id="5" name="Text 3"/>
+          <p:cNvSpPr/>
+          <p:nvPr/>
+        </p:nvSpPr>
+        <p:spPr>
+          <a:xfrm>
+            <a:off x="457200" y="1280160"/>
+            <a:ext cx="6400800" cy="457200"/>
+          </a:xfrm>
+          <a:prstGeom prst="rect">
+            <a:avLst/>
+          </a:prstGeom>
+          <a:noFill/>
+          <a:ln/>
+        </p:spPr>
+        <p:txBody>
+          <a:bodyPr wrap="square" rtlCol="0" anchor="ctr"/>
+          <a:lstStyle/>
+          <a:p>
+            <a:pPr indent="0" marL="0">
+              <a:buNone/>
+            </a:pPr>
+            <a:r>
+              <a:rPr lang="en-US" sz="1400" b="1" dirty="0">
+                <a:solidFill>
+                  <a:srgbClr val="4F46E5"/>
+                </a:solidFill>
+              </a:rPr>
+              <a:t>De la mise au versement</a:t>
+            </a:r>
+            <a:endParaRPr lang="en-US" sz="1400" dirty="0"/>
+          </a:p>
+        </p:txBody>
+      </p:sp>
+      <p:sp>
+        <p:nvSpPr>
+          <p:cNvPr id="6" name="Shape 4"/>
+          <p:cNvSpPr/>
+          <p:nvPr/>
+        </p:nvSpPr>
+        <p:spPr>
+          <a:xfrm>
+            <a:off x="457200" y="1828800"/>
+            <a:ext cx="457200" cy="457200"/>
+          </a:xfrm>
+          <a:prstGeom prst="ellipse">
+            <a:avLst/>
+          </a:prstGeom>
+          <a:solidFill>
+            <a:srgbClr val="4F46E5"/>
+          </a:solidFill>
+          <a:ln w="12700">
+            <a:solidFill>
+              <a:srgbClr val="4F46E5"/>
+            </a:solidFill>
+            <a:prstDash val="solid"/>
+          </a:ln>
+        </p:spPr>
+      </p:sp>
+      <p:sp>
+        <p:nvSpPr>
+          <p:cNvPr id="7" name="Text 5"/>
+          <p:cNvSpPr/>
+          <p:nvPr/>
+        </p:nvSpPr>
+        <p:spPr>
+          <a:xfrm>
+            <a:off x="457200" y="1828800"/>
+            <a:ext cx="457200" cy="457200"/>
+          </a:xfrm>
+          <a:prstGeom prst="rect">
+            <a:avLst/>
+          </a:prstGeom>
+          <a:noFill/>
+          <a:ln/>
+        </p:spPr>
+        <p:txBody>
+          <a:bodyPr wrap="square" rtlCol="0" anchor="ctr"/>
+          <a:lstStyle/>
+          <a:p>
+            <a:pPr algn="ctr" indent="0" marL="0">
+              <a:buNone/>
+            </a:pPr>
+            <a:r>
+              <a:rPr lang="en-US" sz="1300" b="1" dirty="0">
+                <a:solidFill>
+                  <a:srgbClr val="FFFFFF"/>
+                </a:solidFill>
+              </a:rPr>
+              <a:t>1</a:t>
+            </a:r>
+            <a:endParaRPr lang="en-US" sz="1300" dirty="0"/>
+          </a:p>
+        </p:txBody>
+      </p:sp>
+      <p:sp>
+        <p:nvSpPr>
+          <p:cNvPr id="8" name="Text 6"/>
+          <p:cNvSpPr/>
+          <p:nvPr/>
+        </p:nvSpPr>
+        <p:spPr>
+          <a:xfrm>
+            <a:off x="1097280" y="1828800"/>
+            <a:ext cx="5760720" cy="274320"/>
+          </a:xfrm>
+          <a:prstGeom prst="rect">
+            <a:avLst/>
+          </a:prstGeom>
+          <a:noFill/>
+          <a:ln/>
+        </p:spPr>
+        <p:txBody>
+          <a:bodyPr wrap="square" rtlCol="0" anchor="ctr"/>
+          <a:lstStyle/>
+          <a:p>
+            <a:pPr indent="0" marL="0">
+              <a:buNone/>
+            </a:pPr>
+            <a:r>
+              <a:rPr lang="en-US" sz="1200" b="1" dirty="0">
+                <a:solidFill>
+                  <a:srgbClr val="1E293B"/>
+                </a:solidFill>
+              </a:rPr>
+              <a:t>Chaque membre choisit sa mise</a:t>
+            </a:r>
+            <a:endParaRPr lang="en-US" sz="1200" dirty="0"/>
+          </a:p>
+        </p:txBody>
+      </p:sp>
+      <p:sp>
+        <p:nvSpPr>
+          <p:cNvPr id="9" name="Text 7"/>
+          <p:cNvSpPr/>
+          <p:nvPr/>
+        </p:nvSpPr>
+        <p:spPr>
+          <a:xfrm>
+            <a:off x="1097280" y="2084832"/>
+            <a:ext cx="5760720" cy="365760"/>
+          </a:xfrm>
+          <a:prstGeom prst="rect">
+            <a:avLst/>
+          </a:prstGeom>
+          <a:noFill/>
+          <a:ln/>
+        </p:spPr>
+        <p:txBody>
+          <a:bodyPr wrap="square" rtlCol="0" anchor="ctr"/>
+          <a:lstStyle/>
+          <a:p>
+            <a:pPr indent="0" marL="0">
+              <a:buNone/>
+            </a:pPr>
+            <a:r>
+              <a:rPr lang="en-US" sz="1000" dirty="0">
+                <a:solidFill>
+                  <a:srgbClr val="64748B"/>
+                </a:solidFill>
+              </a:rPr>
+              <a:t>Libre : 10 000, 25 000, 60 000… FCFA par mois</a:t>
+            </a:r>
+            <a:endParaRPr lang="en-US" sz="1000" dirty="0"/>
+          </a:p>
+        </p:txBody>
+      </p:sp>
+      <p:sp>
+        <p:nvSpPr>
+          <p:cNvPr id="10" name="Shape 8"/>
+          <p:cNvSpPr/>
+          <p:nvPr/>
+        </p:nvSpPr>
+        <p:spPr>
+          <a:xfrm>
+            <a:off x="457200" y="2834640"/>
+            <a:ext cx="457200" cy="457200"/>
+          </a:xfrm>
+          <a:prstGeom prst="ellipse">
+            <a:avLst/>
+          </a:prstGeom>
+          <a:solidFill>
+            <a:srgbClr val="4F46E5"/>
+          </a:solidFill>
+          <a:ln w="12700">
+            <a:solidFill>
+              <a:srgbClr val="4F46E5"/>
+            </a:solidFill>
+            <a:prstDash val="solid"/>
+          </a:ln>
+        </p:spPr>
+      </p:sp>
+      <p:sp>
+        <p:nvSpPr>
+          <p:cNvPr id="11" name="Text 9"/>
+          <p:cNvSpPr/>
+          <p:nvPr/>
+        </p:nvSpPr>
+        <p:spPr>
+          <a:xfrm>
+            <a:off x="457200" y="2834640"/>
+            <a:ext cx="457200" cy="457200"/>
+          </a:xfrm>
+          <a:prstGeom prst="rect">
+            <a:avLst/>
+          </a:prstGeom>
+          <a:noFill/>
+          <a:ln/>
+        </p:spPr>
+        <p:txBody>
+          <a:bodyPr wrap="square" rtlCol="0" anchor="ctr"/>
+          <a:lstStyle/>
+          <a:p>
+            <a:pPr algn="ctr" indent="0" marL="0">
+              <a:buNone/>
+            </a:pPr>
+            <a:r>
+              <a:rPr lang="en-US" sz="1300" b="1" dirty="0">
+                <a:solidFill>
+                  <a:srgbClr val="FFFFFF"/>
+                </a:solidFill>
+              </a:rPr>
+              <a:t>2</a:t>
+            </a:r>
+            <a:endParaRPr lang="en-US" sz="1300" dirty="0"/>
+          </a:p>
+        </p:txBody>
+      </p:sp>
+      <p:sp>
+        <p:nvSpPr>
+          <p:cNvPr id="12" name="Text 10"/>
+          <p:cNvSpPr/>
+          <p:nvPr/>
+        </p:nvSpPr>
+        <p:spPr>
+          <a:xfrm>
+            <a:off x="1097280" y="2834640"/>
+            <a:ext cx="5760720" cy="274320"/>
+          </a:xfrm>
+          <a:prstGeom prst="rect">
+            <a:avLst/>
+          </a:prstGeom>
+          <a:noFill/>
+          <a:ln/>
+        </p:spPr>
+        <p:txBody>
+          <a:bodyPr wrap="square" rtlCol="0" anchor="ctr"/>
+          <a:lstStyle/>
+          <a:p>
+            <a:pPr indent="0" marL="0">
+              <a:buNone/>
+            </a:pPr>
+            <a:r>
+              <a:rPr lang="en-US" sz="1200" b="1" dirty="0">
+                <a:solidFill>
+                  <a:srgbClr val="1E293B"/>
+                </a:solidFill>
+              </a:rPr>
+              <a:t>L'application compose des lots exacts</a:t>
+            </a:r>
+            <a:endParaRPr lang="en-US" sz="1200" dirty="0"/>
+          </a:p>
+        </p:txBody>
+      </p:sp>
+      <p:sp>
+        <p:nvSpPr>
+          <p:cNvPr id="13" name="Text 11"/>
+          <p:cNvSpPr/>
+          <p:nvPr/>
+        </p:nvSpPr>
+        <p:spPr>
+          <a:xfrm>
+            <a:off x="1097280" y="3090672"/>
+            <a:ext cx="5760720" cy="365760"/>
+          </a:xfrm>
+          <a:prstGeom prst="rect">
+            <a:avLst/>
+          </a:prstGeom>
+          <a:noFill/>
+          <a:ln/>
+        </p:spPr>
+        <p:txBody>
+          <a:bodyPr wrap="square" rtlCol="0" anchor="ctr"/>
+          <a:lstStyle/>
+          <a:p>
+            <a:pPr indent="0" marL="0">
+              <a:buNone/>
+            </a:pPr>
+            <a:r>
+              <a:rPr lang="en-US" sz="1000" dirty="0">
+                <a:solidFill>
+                  <a:srgbClr val="64748B"/>
+                </a:solidFill>
+              </a:rPr>
+              <a:t>10 000 + 10 000 + 30 000 = un lot de 50 000 ; le bureau ajuste puis fige</a:t>
+            </a:r>
+            <a:endParaRPr lang="en-US" sz="1000" dirty="0"/>
+          </a:p>
+        </p:txBody>
+      </p:sp>
+      <p:sp>
+        <p:nvSpPr>
+          <p:cNvPr id="14" name="Shape 12"/>
+          <p:cNvSpPr/>
+          <p:nvPr/>
+        </p:nvSpPr>
+        <p:spPr>
+          <a:xfrm>
+            <a:off x="457200" y="3840480"/>
+            <a:ext cx="457200" cy="457200"/>
+          </a:xfrm>
+          <a:prstGeom prst="ellipse">
+            <a:avLst/>
+          </a:prstGeom>
+          <a:solidFill>
+            <a:srgbClr val="4F46E5"/>
+          </a:solidFill>
+          <a:ln w="12700">
+            <a:solidFill>
+              <a:srgbClr val="4F46E5"/>
+            </a:solidFill>
+            <a:prstDash val="solid"/>
+          </a:ln>
+        </p:spPr>
+      </p:sp>
+      <p:sp>
+        <p:nvSpPr>
+          <p:cNvPr id="15" name="Text 13"/>
+          <p:cNvSpPr/>
+          <p:nvPr/>
+        </p:nvSpPr>
+        <p:spPr>
+          <a:xfrm>
+            <a:off x="457200" y="3840480"/>
+            <a:ext cx="457200" cy="457200"/>
+          </a:xfrm>
+          <a:prstGeom prst="rect">
+            <a:avLst/>
+          </a:prstGeom>
+          <a:noFill/>
+          <a:ln/>
+        </p:spPr>
+        <p:txBody>
+          <a:bodyPr wrap="square" rtlCol="0" anchor="ctr"/>
+          <a:lstStyle/>
+          <a:p>
+            <a:pPr algn="ctr" indent="0" marL="0">
+              <a:buNone/>
+            </a:pPr>
+            <a:r>
+              <a:rPr lang="en-US" sz="1300" b="1" dirty="0">
+                <a:solidFill>
+                  <a:srgbClr val="FFFFFF"/>
+                </a:solidFill>
+              </a:rPr>
+              <a:t>3</a:t>
+            </a:r>
+            <a:endParaRPr lang="en-US" sz="1300" dirty="0"/>
+          </a:p>
+        </p:txBody>
+      </p:sp>
+      <p:sp>
+        <p:nvSpPr>
+          <p:cNvPr id="16" name="Text 14"/>
+          <p:cNvSpPr/>
+          <p:nvPr/>
+        </p:nvSpPr>
+        <p:spPr>
+          <a:xfrm>
+            <a:off x="1097280" y="3840480"/>
+            <a:ext cx="5760720" cy="274320"/>
+          </a:xfrm>
+          <a:prstGeom prst="rect">
+            <a:avLst/>
+          </a:prstGeom>
+          <a:noFill/>
+          <a:ln/>
+        </p:spPr>
+        <p:txBody>
+          <a:bodyPr wrap="square" rtlCol="0" anchor="ctr"/>
+          <a:lstStyle/>
+          <a:p>
+            <a:pPr indent="0" marL="0">
+              <a:buNone/>
+            </a:pPr>
+            <a:r>
+              <a:rPr lang="en-US" sz="1200" b="1" dirty="0">
+                <a:solidFill>
+                  <a:srgbClr val="1E293B"/>
+                </a:solidFill>
+              </a:rPr>
+              <a:t>Chaque part est versée séparément</a:t>
+            </a:r>
+            <a:endParaRPr lang="en-US" sz="1200" dirty="0"/>
+          </a:p>
+        </p:txBody>
+      </p:sp>
+      <p:sp>
+        <p:nvSpPr>
+          <p:cNvPr id="17" name="Text 15"/>
+          <p:cNvSpPr/>
+          <p:nvPr/>
+        </p:nvSpPr>
+        <p:spPr>
+          <a:xfrm>
+            <a:off x="1097280" y="4096512"/>
+            <a:ext cx="5760720" cy="365760"/>
+          </a:xfrm>
+          <a:prstGeom prst="rect">
+            <a:avLst/>
+          </a:prstGeom>
+          <a:noFill/>
+          <a:ln/>
+        </p:spPr>
+        <p:txBody>
+          <a:bodyPr wrap="square" rtlCol="0" anchor="ctr"/>
+          <a:lstStyle/>
+          <a:p>
+            <a:pPr indent="0" marL="0">
+              <a:buNone/>
+            </a:pPr>
+            <a:r>
+              <a:rPr lang="en-US" sz="1000" dirty="0">
+                <a:solidFill>
+                  <a:srgbClr val="64748B"/>
+                </a:solidFill>
+              </a:rPr>
+              <a:t>Mise × nombre de tours, moins le reste dû du fond de caisse</a:t>
+            </a:r>
+            <a:endParaRPr lang="en-US" sz="1000" dirty="0"/>
+          </a:p>
+        </p:txBody>
+      </p:sp>
+      <p:sp>
+        <p:nvSpPr>
+          <p:cNvPr id="18" name="Shape 16"/>
+          <p:cNvSpPr/>
+          <p:nvPr/>
+        </p:nvSpPr>
+        <p:spPr>
+          <a:xfrm>
+            <a:off x="457200" y="4846320"/>
+            <a:ext cx="457200" cy="457200"/>
+          </a:xfrm>
+          <a:prstGeom prst="ellipse">
+            <a:avLst/>
+          </a:prstGeom>
+          <a:solidFill>
+            <a:srgbClr val="4F46E5"/>
+          </a:solidFill>
+          <a:ln w="12700">
+            <a:solidFill>
+              <a:srgbClr val="4F46E5"/>
+            </a:solidFill>
+            <a:prstDash val="solid"/>
+          </a:ln>
+        </p:spPr>
+      </p:sp>
+      <p:sp>
+        <p:nvSpPr>
+          <p:cNvPr id="19" name="Text 17"/>
+          <p:cNvSpPr/>
+          <p:nvPr/>
+        </p:nvSpPr>
+        <p:spPr>
+          <a:xfrm>
+            <a:off x="457200" y="4846320"/>
+            <a:ext cx="457200" cy="457200"/>
+          </a:xfrm>
+          <a:prstGeom prst="rect">
+            <a:avLst/>
+          </a:prstGeom>
+          <a:noFill/>
+          <a:ln/>
+        </p:spPr>
+        <p:txBody>
+          <a:bodyPr wrap="square" rtlCol="0" anchor="ctr"/>
+          <a:lstStyle/>
+          <a:p>
+            <a:pPr algn="ctr" indent="0" marL="0">
+              <a:buNone/>
+            </a:pPr>
+            <a:r>
+              <a:rPr lang="en-US" sz="1300" b="1" dirty="0">
+                <a:solidFill>
+                  <a:srgbClr val="FFFFFF"/>
+                </a:solidFill>
+              </a:rPr>
+              <a:t>4</a:t>
+            </a:r>
+            <a:endParaRPr lang="en-US" sz="1300" dirty="0"/>
+          </a:p>
+        </p:txBody>
+      </p:sp>
+      <p:sp>
+        <p:nvSpPr>
+          <p:cNvPr id="20" name="Text 18"/>
+          <p:cNvSpPr/>
+          <p:nvPr/>
+        </p:nvSpPr>
+        <p:spPr>
+          <a:xfrm>
+            <a:off x="1097280" y="4846320"/>
+            <a:ext cx="5760720" cy="274320"/>
+          </a:xfrm>
+          <a:prstGeom prst="rect">
+            <a:avLst/>
+          </a:prstGeom>
+          <a:noFill/>
+          <a:ln/>
+        </p:spPr>
+        <p:txBody>
+          <a:bodyPr wrap="square" rtlCol="0" anchor="ctr"/>
+          <a:lstStyle/>
+          <a:p>
+            <a:pPr indent="0" marL="0">
+              <a:buNone/>
+            </a:pPr>
+            <a:r>
+              <a:rPr lang="en-US" sz="1200" b="1" dirty="0">
+                <a:solidFill>
+                  <a:srgbClr val="1E293B"/>
+                </a:solidFill>
+              </a:rPr>
+              <a:t>Un départ ne bloque pas le groupe</a:t>
+            </a:r>
+            <a:endParaRPr lang="en-US" sz="1200" dirty="0"/>
+          </a:p>
+        </p:txBody>
+      </p:sp>
+      <p:sp>
+        <p:nvSpPr>
+          <p:cNvPr id="21" name="Text 19"/>
+          <p:cNvSpPr/>
+          <p:nvPr/>
+        </p:nvSpPr>
+        <p:spPr>
+          <a:xfrm>
+            <a:off x="1097280" y="5102352"/>
+            <a:ext cx="5760720" cy="365760"/>
+          </a:xfrm>
+          <a:prstGeom prst="rect">
+            <a:avLst/>
+          </a:prstGeom>
+          <a:noFill/>
+          <a:ln/>
+        </p:spPr>
+        <p:txBody>
+          <a:bodyPr wrap="square" rtlCol="0" anchor="ctr"/>
+          <a:lstStyle/>
+          <a:p>
+            <a:pPr indent="0" marL="0">
+              <a:buNone/>
+            </a:pPr>
+            <a:r>
+              <a:rPr lang="en-US" sz="1000" dirty="0">
+                <a:solidFill>
+                  <a:srgbClr val="64748B"/>
+                </a:solidFill>
+              </a:rPr>
+              <a:t>Avant son tour : avoir gelé, rendu en fin de session. Après : dette suivie</a:t>
+            </a:r>
+            <a:endParaRPr lang="en-US" sz="1000" dirty="0"/>
+          </a:p>
+        </p:txBody>
+      </p:sp>
+      <p:sp>
+        <p:nvSpPr>
+          <p:cNvPr id="22" name="Shape 20"/>
+          <p:cNvSpPr/>
+          <p:nvPr/>
+        </p:nvSpPr>
+        <p:spPr>
+          <a:xfrm>
+            <a:off x="7406640" y="1188720"/>
+            <a:ext cx="4114800" cy="4846320"/>
+          </a:xfrm>
+          <a:prstGeom prst="roundRect">
+            <a:avLst/>
+          </a:prstGeom>
+          <a:solidFill>
+            <a:srgbClr val="EEF2FF"/>
+          </a:solidFill>
+          <a:ln w="12700">
+            <a:solidFill>
+              <a:srgbClr val="C7D2FE"/>
+            </a:solidFill>
+            <a:prstDash val="solid"/>
+          </a:ln>
+        </p:spPr>
+      </p:sp>
+      <p:sp>
+        <p:nvSpPr>
+          <p:cNvPr id="23" name="Text 21"/>
+          <p:cNvSpPr/>
+          <p:nvPr/>
+        </p:nvSpPr>
+        <p:spPr>
+          <a:xfrm>
+            <a:off x="7589520" y="1280160"/>
+            <a:ext cx="3749040" cy="457200"/>
+          </a:xfrm>
+          <a:prstGeom prst="rect">
+            <a:avLst/>
+          </a:prstGeom>
+          <a:noFill/>
+          <a:ln/>
+        </p:spPr>
+        <p:txBody>
+          <a:bodyPr wrap="square" rtlCol="0" anchor="ctr"/>
+          <a:lstStyle/>
+          <a:p>
+            <a:pPr indent="0" marL="0">
+              <a:buNone/>
+            </a:pPr>
+            <a:r>
+              <a:rPr lang="en-US" sz="1300" b="1" dirty="0">
+                <a:solidFill>
+                  <a:srgbClr val="4338CA"/>
+                </a:solidFill>
+              </a:rPr>
+              <a:t>Ce que le bureau maîtrise</a:t>
+            </a:r>
+            <a:endParaRPr lang="en-US" sz="1300" dirty="0"/>
+          </a:p>
+        </p:txBody>
+      </p:sp>
+      <p:sp>
+        <p:nvSpPr>
+          <p:cNvPr id="24" name="Text 22"/>
+          <p:cNvSpPr/>
+          <p:nvPr/>
+        </p:nvSpPr>
+        <p:spPr>
+          <a:xfrm>
+            <a:off x="7589520" y="1920240"/>
+            <a:ext cx="3749040" cy="548640"/>
+          </a:xfrm>
+          <a:prstGeom prst="rect">
+            <a:avLst/>
+          </a:prstGeom>
+          <a:noFill/>
+          <a:ln/>
+        </p:spPr>
+        <p:txBody>
+          <a:bodyPr wrap="square" rtlCol="0" anchor="ctr"/>
+          <a:lstStyle/>
+          <a:p>
+            <a:pPr indent="0" marL="0">
+              <a:buNone/>
+            </a:pPr>
+            <a:r>
+              <a:rPr lang="en-US" sz="1100" dirty="0">
+                <a:solidFill>
+                  <a:srgbClr val="3730A3"/>
+                </a:solidFill>
+              </a:rPr>
+              <a:t>✅  Composition ajustable avant figeage</a:t>
+            </a:r>
+            <a:endParaRPr lang="en-US" sz="1100" dirty="0"/>
+          </a:p>
+        </p:txBody>
+      </p:sp>
+      <p:sp>
+        <p:nvSpPr>
+          <p:cNvPr id="25" name="Text 23"/>
+          <p:cNvSpPr/>
+          <p:nvPr/>
+        </p:nvSpPr>
+        <p:spPr>
+          <a:xfrm>
+            <a:off x="7589520" y="2560320"/>
+            <a:ext cx="3749040" cy="548640"/>
+          </a:xfrm>
+          <a:prstGeom prst="rect">
+            <a:avLst/>
+          </a:prstGeom>
+          <a:noFill/>
+          <a:ln/>
+        </p:spPr>
+        <p:txBody>
+          <a:bodyPr wrap="square" rtlCol="0" anchor="ctr"/>
+          <a:lstStyle/>
+          <a:p>
+            <a:pPr indent="0" marL="0">
+              <a:buNone/>
+            </a:pPr>
+            <a:r>
+              <a:rPr lang="en-US" sz="1100" dirty="0">
+                <a:solidFill>
+                  <a:srgbClr val="3730A3"/>
+                </a:solidFill>
+              </a:rPr>
+              <a:t>✅  Aucune mise perdue en trésorerie</a:t>
+            </a:r>
+            <a:endParaRPr lang="en-US" sz="1100" dirty="0"/>
+          </a:p>
+        </p:txBody>
+      </p:sp>
+      <p:sp>
+        <p:nvSpPr>
+          <p:cNvPr id="26" name="Text 24"/>
+          <p:cNvSpPr/>
+          <p:nvPr/>
+        </p:nvSpPr>
+        <p:spPr>
+          <a:xfrm>
+            <a:off x="7589520" y="3200400"/>
+            <a:ext cx="3749040" cy="548640"/>
+          </a:xfrm>
+          <a:prstGeom prst="rect">
+            <a:avLst/>
+          </a:prstGeom>
+          <a:noFill/>
+          <a:ln/>
+        </p:spPr>
+        <p:txBody>
+          <a:bodyPr wrap="square" rtlCol="0" anchor="ctr"/>
+          <a:lstStyle/>
+          <a:p>
+            <a:pPr indent="0" marL="0">
+              <a:buNone/>
+            </a:pPr>
+            <a:r>
+              <a:rPr lang="en-US" sz="1100" dirty="0">
+                <a:solidFill>
+                  <a:srgbClr val="3730A3"/>
+                </a:solidFill>
+              </a:rPr>
+              <a:t>✅  Retenue du fond membre par membre</a:t>
+            </a:r>
+            <a:endParaRPr lang="en-US" sz="1100" dirty="0"/>
+          </a:p>
+        </p:txBody>
+      </p:sp>
+      <p:sp>
+        <p:nvSpPr>
+          <p:cNvPr id="27" name="Text 25"/>
+          <p:cNvSpPr/>
+          <p:nvPr/>
+        </p:nvSpPr>
+        <p:spPr>
+          <a:xfrm>
+            <a:off x="7589520" y="3840480"/>
+            <a:ext cx="3749040" cy="548640"/>
+          </a:xfrm>
+          <a:prstGeom prst="rect">
+            <a:avLst/>
+          </a:prstGeom>
+          <a:noFill/>
+          <a:ln/>
+        </p:spPr>
+        <p:txBody>
+          <a:bodyPr wrap="square" rtlCol="0" anchor="ctr"/>
+          <a:lstStyle/>
+          <a:p>
+            <a:pPr indent="0" marL="0">
+              <a:buNone/>
+            </a:pPr>
+            <a:r>
+              <a:rPr lang="en-US" sz="1100" dirty="0">
+                <a:solidFill>
+                  <a:srgbClr val="3730A3"/>
+                </a:solidFill>
+              </a:rPr>
+              <a:t>✅  Rapport de tour par bénéficiaire</a:t>
+            </a:r>
+            <a:endParaRPr lang="en-US" sz="1100" dirty="0"/>
+          </a:p>
+        </p:txBody>
+      </p:sp>
+      <p:sp>
+        <p:nvSpPr>
+          <p:cNvPr id="28" name="Text 26"/>
+          <p:cNvSpPr/>
+          <p:nvPr/>
+        </p:nvSpPr>
+        <p:spPr>
+          <a:xfrm>
+            <a:off x="7589520" y="4480560"/>
+            <a:ext cx="3749040" cy="548640"/>
+          </a:xfrm>
+          <a:prstGeom prst="rect">
+            <a:avLst/>
+          </a:prstGeom>
+          <a:noFill/>
+          <a:ln/>
+        </p:spPr>
+        <p:txBody>
+          <a:bodyPr wrap="square" rtlCol="0" anchor="ctr"/>
+          <a:lstStyle/>
+          <a:p>
+            <a:pPr indent="0" marL="0">
+              <a:buNone/>
+            </a:pPr>
+            <a:r>
+              <a:rPr lang="en-US" sz="1100" dirty="0">
+                <a:solidFill>
+                  <a:srgbClr val="3730A3"/>
+                </a:solidFill>
+              </a:rPr>
+              <a:t>✅  Avoirs gelés et dettes suivis</a:t>
+            </a:r>
+            <a:endParaRPr lang="en-US" sz="1100" dirty="0"/>
+          </a:p>
+        </p:txBody>
+      </p:sp>
+      <p:sp>
+        <p:nvSpPr>
+          <p:cNvPr id="29" name="Text 27"/>
+          <p:cNvSpPr/>
+          <p:nvPr/>
+        </p:nvSpPr>
+        <p:spPr>
+          <a:xfrm>
+            <a:off x="7589520" y="5120640"/>
+            <a:ext cx="3749040" cy="548640"/>
+          </a:xfrm>
+          <a:prstGeom prst="rect">
+            <a:avLst/>
+          </a:prstGeom>
+          <a:noFill/>
+          <a:ln/>
+        </p:spPr>
+        <p:txBody>
+          <a:bodyPr wrap="square" rtlCol="0" anchor="ctr"/>
+          <a:lstStyle/>
+          <a:p>
+            <a:pPr indent="0" marL="0">
+              <a:buNone/>
+            </a:pPr>
+            <a:r>
+              <a:rPr lang="en-US" sz="1100" dirty="0">
+                <a:solidFill>
+                  <a:srgbClr val="3730A3"/>
+                </a:solidFill>
+              </a:rPr>
+              <a:t>✅  Trésorerie de la session en direct</a:t>
+            </a:r>
+            <a:endParaRPr lang="en-US" sz="1100" dirty="0"/>
+          </a:p>
+        </p:txBody>
+      </p:sp>
+      <p:sp>
+        <p:nvSpPr>
+          <p:cNvPr id="30" name="Text 28"/>
+          <p:cNvSpPr/>
+          <p:nvPr/>
+        </p:nvSpPr>
+        <p:spPr>
+          <a:xfrm>
+            <a:off x="274320" y="6309360"/>
+            <a:ext cx="10972800" cy="274320"/>
+          </a:xfrm>
+          <a:prstGeom prst="rect">
+            <a:avLst/>
+          </a:prstGeom>
+          <a:noFill/>
+          <a:ln/>
+        </p:spPr>
+        <p:txBody>
+          <a:bodyPr wrap="square" rtlCol="0" anchor="ctr"/>
+          <a:lstStyle/>
+          <a:p>
+            <a:pPr algn="ctr" indent="0" marL="0">
+              <a:buNone/>
+            </a:pPr>
+            <a:r>
+              <a:rPr lang="en-US" sz="800" dirty="0">
+                <a:solidFill>
+                  <a:srgbClr val="94A3B8"/>
+                </a:solidFill>
+              </a:rPr>
+              <a:t>TontinePro v1.6  ·  JumpyTech  ·  © 2026</a:t>
+            </a:r>
+            <a:endParaRPr lang="en-US" sz="800" dirty="0"/>
+          </a:p>
+        </p:txBody>
+      </p:sp>
+      <p:sp>
+        <p:nvSpPr>
+          <p:cNvPr id="31" name="Text 29"/>
+          <p:cNvSpPr/>
+          <p:nvPr/>
+        </p:nvSpPr>
+        <p:spPr>
+          <a:xfrm>
+            <a:off x="11155680" y="6309360"/>
+            <a:ext cx="457200" cy="274320"/>
+          </a:xfrm>
+          <a:prstGeom prst="rect">
+            <a:avLst/>
+          </a:prstGeom>
+          <a:noFill/>
+          <a:ln/>
+        </p:spPr>
+        <p:txBody>
+          <a:bodyPr wrap="square" rtlCol="0" anchor="ctr"/>
+          <a:lstStyle/>
+          <a:p>
+            <a:pPr algn="r" indent="0" marL="0">
+              <a:buNone/>
+            </a:pPr>
+            <a:r>
+              <a:rPr lang="en-US" sz="800" dirty="0">
+                <a:solidFill>
+                  <a:srgbClr val="94A3B8"/>
+                </a:solidFill>
+              </a:rPr>
+              <a:t>7</a:t>
+            </a:r>
+            <a:endParaRPr lang="en-US" sz="800" dirty="0"/>
+          </a:p>
+        </p:txBody>
+      </p:sp>
+    </p:spTree>
+  </p:cSld>
+  <p:clrMapOvr>
+    <a:masterClrMapping/>
+  </p:clrMapOvr>
+</p:sld>
+</file>
+
+<file path=ppt/slides/slide8.xml><?xml version="1.0" encoding="utf-8"?>
+<p:sld xmlns:a="http://schemas.openxmlformats.org/drawingml/2006/main" xmlns:r="http://schemas.openxmlformats.org/officeDocument/2006/relationships" xmlns:p="http://schemas.openxmlformats.org/presentationml/2006/main">
+  <p:cSld name="Slide 8">
     <p:bg>
       <p:bgPr>
         <a:solidFill>
@@ -8314,7 +9449,7 @@
                   <a:srgbClr val="94A3B8"/>
                 </a:solidFill>
               </a:rPr>
-              <a:t>TontinePro v1.1  ·  JumpyTech  ·  © 2026</a:t>
+              <a:t>TontinePro v1.6  ·  JumpyTech  ·  © 2026</a:t>
             </a:r>
             <a:endParaRPr lang="en-US" sz="800" dirty="0"/>
           </a:p>
@@ -8350,7 +9485,7 @@
                   <a:srgbClr val="94A3B8"/>
                 </a:solidFill>
               </a:rPr>
-              <a:t>7</a:t>
+              <a:t>8</a:t>
             </a:r>
             <a:endParaRPr lang="en-US" sz="800" dirty="0"/>
           </a:p>
@@ -8364,9 +9499,9 @@
 </p:sld>
 </file>
 
-<file path=ppt/slides/slide8.xml><?xml version="1.0" encoding="utf-8"?>
+<file path=ppt/slides/slide9.xml><?xml version="1.0" encoding="utf-8"?>
 <p:sld xmlns:a="http://schemas.openxmlformats.org/drawingml/2006/main" xmlns:r="http://schemas.openxmlformats.org/officeDocument/2006/relationships" xmlns:p="http://schemas.openxmlformats.org/presentationml/2006/main">
-  <p:cSld name="Slide 8">
+  <p:cSld name="Slide 9">
     <p:bg>
       <p:bgPr>
         <a:solidFill>

</xml_diff>

<commit_message>
docs: guide, presentation et PPTX v1.7 (tour de remboursement, depart en session pas figee, montant remis, correction et avance sur un tour)
</commit_message>
<xml_diff>
--- a/tontinepro-frontend/public/docs/TontinePro-Presentation.pptx
+++ b/tontinepro-frontend/public/docs/TontinePro-Presentation.pptx
@@ -1764,7 +1764,7 @@
                   <a:srgbClr val="818CF8"/>
                 </a:solidFill>
               </a:rPr>
-              <a:t>Version 1.6  ·  Octobre 2026  ·  JumpyTech</a:t>
+              <a:t>Version 1.7  ·  Octobre 2026  ·  JumpyTech</a:t>
             </a:r>
             <a:endParaRPr lang="en-US" sz="1300" dirty="0"/>
           </a:p>
@@ -2494,7 +2494,7 @@
                   <a:srgbClr val="94A3B8"/>
                 </a:solidFill>
               </a:rPr>
-              <a:t>TontinePro v1.6  ·  JumpyTech  ·  © 2026</a:t>
+              <a:t>TontinePro v1.7  ·  JumpyTech  ·  © 2026</a:t>
             </a:r>
             <a:endParaRPr lang="en-US" sz="800" dirty="0"/>
           </a:p>
@@ -4266,7 +4266,7 @@
                   <a:srgbClr val="94A3B8"/>
                 </a:solidFill>
               </a:rPr>
-              <a:t>TontinePro v1.6  ·  JumpyTech  ·  © 2026</a:t>
+              <a:t>TontinePro v1.7  ·  JumpyTech  ·  © 2026</a:t>
             </a:r>
             <a:endParaRPr lang="en-US" sz="800" dirty="0"/>
           </a:p>
@@ -5240,7 +5240,7 @@
                   <a:srgbClr val="94A3B8"/>
                 </a:solidFill>
               </a:rPr>
-              <a:t>TontinePro v1.6  ·  JumpyTech  ·  © 2026</a:t>
+              <a:t>TontinePro v1.7  ·  JumpyTech  ·  © 2026</a:t>
             </a:r>
             <a:endParaRPr lang="en-US" sz="800" dirty="0"/>
           </a:p>
@@ -6286,7 +6286,7 @@
                   <a:srgbClr val="94A3B8"/>
                 </a:solidFill>
               </a:rPr>
-              <a:t>TontinePro v1.6  ·  JumpyTech  ·  © 2026</a:t>
+              <a:t>TontinePro v1.7  ·  JumpyTech  ·  © 2026</a:t>
             </a:r>
             <a:endParaRPr lang="en-US" sz="800" dirty="0"/>
           </a:p>
@@ -7332,7 +7332,7 @@
                   <a:srgbClr val="94A3B8"/>
                 </a:solidFill>
               </a:rPr>
-              <a:t>TontinePro v1.6  ·  JumpyTech  ·  © 2026</a:t>
+              <a:t>TontinePro v1.7  ·  JumpyTech  ·  © 2026</a:t>
             </a:r>
             <a:endParaRPr lang="en-US" sz="800" dirty="0"/>
           </a:p>
@@ -8065,7 +8065,7 @@
                   <a:srgbClr val="64748B"/>
                 </a:solidFill>
               </a:rPr>
-              <a:t>Avant son tour : avoir gelé, rendu en fin de session. Après : dette suivie</a:t>
+              <a:t>Avant son tour : avoir gelé, rendu au tour de remboursement. Après : dette suivie</a:t>
             </a:r>
             <a:endParaRPr lang="en-US" sz="1000" dirty="0"/>
           </a:p>
@@ -8176,7 +8176,7 @@
         </p:nvSpPr>
         <p:spPr>
           <a:xfrm>
-            <a:off x="7589520" y="2560320"/>
+            <a:off x="7589520" y="2487168"/>
             <a:ext cx="3749040" cy="548640"/>
           </a:xfrm>
           <a:prstGeom prst="rect">
@@ -8212,7 +8212,7 @@
         </p:nvSpPr>
         <p:spPr>
           <a:xfrm>
-            <a:off x="7589520" y="3200400"/>
+            <a:off x="7589520" y="3054096"/>
             <a:ext cx="3749040" cy="548640"/>
           </a:xfrm>
           <a:prstGeom prst="rect">
@@ -8248,7 +8248,7 @@
         </p:nvSpPr>
         <p:spPr>
           <a:xfrm>
-            <a:off x="7589520" y="3840480"/>
+            <a:off x="7589520" y="3621024"/>
             <a:ext cx="3749040" cy="548640"/>
           </a:xfrm>
           <a:prstGeom prst="rect">
@@ -8284,7 +8284,7 @@
         </p:nvSpPr>
         <p:spPr>
           <a:xfrm>
-            <a:off x="7589520" y="4480560"/>
+            <a:off x="7589520" y="4187952"/>
             <a:ext cx="3749040" cy="548640"/>
           </a:xfrm>
           <a:prstGeom prst="rect">
@@ -8320,7 +8320,7 @@
         </p:nvSpPr>
         <p:spPr>
           <a:xfrm>
-            <a:off x="7589520" y="5120640"/>
+            <a:off x="7589520" y="4754880"/>
             <a:ext cx="3749040" cy="548640"/>
           </a:xfrm>
           <a:prstGeom prst="rect">
@@ -8342,6 +8342,42 @@
                   <a:srgbClr val="3730A3"/>
                 </a:solidFill>
               </a:rPr>
+              <a:t>✅  Tour de remboursement des partis</a:t>
+            </a:r>
+            <a:endParaRPr lang="en-US" sz="1100" dirty="0"/>
+          </a:p>
+        </p:txBody>
+      </p:sp>
+      <p:sp>
+        <p:nvSpPr>
+          <p:cNvPr id="30" name="Text 28"/>
+          <p:cNvSpPr/>
+          <p:nvPr/>
+        </p:nvSpPr>
+        <p:spPr>
+          <a:xfrm>
+            <a:off x="7589520" y="5321808"/>
+            <a:ext cx="3749040" cy="548640"/>
+          </a:xfrm>
+          <a:prstGeom prst="rect">
+            <a:avLst/>
+          </a:prstGeom>
+          <a:noFill/>
+          <a:ln/>
+        </p:spPr>
+        <p:txBody>
+          <a:bodyPr wrap="square" rtlCol="0" anchor="ctr"/>
+          <a:lstStyle/>
+          <a:p>
+            <a:pPr indent="0" marL="0">
+              <a:buNone/>
+            </a:pPr>
+            <a:r>
+              <a:rPr lang="en-US" sz="1100" dirty="0">
+                <a:solidFill>
+                  <a:srgbClr val="3730A3"/>
+                </a:solidFill>
+              </a:rPr>
               <a:t>✅  Trésorerie de la session en direct</a:t>
             </a:r>
             <a:endParaRPr lang="en-US" sz="1100" dirty="0"/>
@@ -8350,7 +8386,7 @@
       </p:sp>
       <p:sp>
         <p:nvSpPr>
-          <p:cNvPr id="30" name="Text 28"/>
+          <p:cNvPr id="31" name="Text 29"/>
           <p:cNvSpPr/>
           <p:nvPr/>
         </p:nvSpPr>
@@ -8378,7 +8414,7 @@
                   <a:srgbClr val="94A3B8"/>
                 </a:solidFill>
               </a:rPr>
-              <a:t>TontinePro v1.6  ·  JumpyTech  ·  © 2026</a:t>
+              <a:t>TontinePro v1.7  ·  JumpyTech  ·  © 2026</a:t>
             </a:r>
             <a:endParaRPr lang="en-US" sz="800" dirty="0"/>
           </a:p>
@@ -8386,7 +8422,7 @@
       </p:sp>
       <p:sp>
         <p:nvSpPr>
-          <p:cNvPr id="31" name="Text 29"/>
+          <p:cNvPr id="32" name="Text 30"/>
           <p:cNvSpPr/>
           <p:nvPr/>
         </p:nvSpPr>
@@ -9449,7 +9485,7 @@
                   <a:srgbClr val="94A3B8"/>
                 </a:solidFill>
               </a:rPr>
-              <a:t>TontinePro v1.6  ·  JumpyTech  ·  © 2026</a:t>
+              <a:t>TontinePro v1.7  ·  JumpyTech  ·  © 2026</a:t>
             </a:r>
             <a:endParaRPr lang="en-US" sz="800" dirty="0"/>
           </a:p>

</xml_diff>

<commit_message>
docs: guide v1.8 (solde reporte, arrieres des membres), presentation et PPTX v1.8
</commit_message>
<xml_diff>
--- a/tontinepro-frontend/public/docs/TontinePro-Presentation.pptx
+++ b/tontinepro-frontend/public/docs/TontinePro-Presentation.pptx
@@ -1764,7 +1764,7 @@
                   <a:srgbClr val="818CF8"/>
                 </a:solidFill>
               </a:rPr>
-              <a:t>Version 1.7  ·  Octobre 2026  ·  JumpyTech</a:t>
+              <a:t>Version 1.8  ·  Octobre 2026  ·  JumpyTech</a:t>
             </a:r>
             <a:endParaRPr lang="en-US" sz="1300" dirty="0"/>
           </a:p>
@@ -2494,7 +2494,7 @@
                   <a:srgbClr val="94A3B8"/>
                 </a:solidFill>
               </a:rPr>
-              <a:t>TontinePro v1.7  ·  JumpyTech  ·  © 2026</a:t>
+              <a:t>TontinePro v1.8  ·  JumpyTech  ·  © 2026</a:t>
             </a:r>
             <a:endParaRPr lang="en-US" sz="800" dirty="0"/>
           </a:p>
@@ -4266,7 +4266,7 @@
                   <a:srgbClr val="94A3B8"/>
                 </a:solidFill>
               </a:rPr>
-              <a:t>TontinePro v1.7  ·  JumpyTech  ·  © 2026</a:t>
+              <a:t>TontinePro v1.8  ·  JumpyTech  ·  © 2026</a:t>
             </a:r>
             <a:endParaRPr lang="en-US" sz="800" dirty="0"/>
           </a:p>
@@ -5240,7 +5240,7 @@
                   <a:srgbClr val="94A3B8"/>
                 </a:solidFill>
               </a:rPr>
-              <a:t>TontinePro v1.7  ·  JumpyTech  ·  © 2026</a:t>
+              <a:t>TontinePro v1.8  ·  JumpyTech  ·  © 2026</a:t>
             </a:r>
             <a:endParaRPr lang="en-US" sz="800" dirty="0"/>
           </a:p>
@@ -6286,7 +6286,7 @@
                   <a:srgbClr val="94A3B8"/>
                 </a:solidFill>
               </a:rPr>
-              <a:t>TontinePro v1.7  ·  JumpyTech  ·  © 2026</a:t>
+              <a:t>TontinePro v1.8  ·  JumpyTech  ·  © 2026</a:t>
             </a:r>
             <a:endParaRPr lang="en-US" sz="800" dirty="0"/>
           </a:p>
@@ -7332,7 +7332,7 @@
                   <a:srgbClr val="94A3B8"/>
                 </a:solidFill>
               </a:rPr>
-              <a:t>TontinePro v1.7  ·  JumpyTech  ·  © 2026</a:t>
+              <a:t>TontinePro v1.8  ·  JumpyTech  ·  © 2026</a:t>
             </a:r>
             <a:endParaRPr lang="en-US" sz="800" dirty="0"/>
           </a:p>
@@ -8414,7 +8414,7 @@
                   <a:srgbClr val="94A3B8"/>
                 </a:solidFill>
               </a:rPr>
-              <a:t>TontinePro v1.7  ·  JumpyTech  ·  © 2026</a:t>
+              <a:t>TontinePro v1.8  ·  JumpyTech  ·  © 2026</a:t>
             </a:r>
             <a:endParaRPr lang="en-US" sz="800" dirty="0"/>
           </a:p>
@@ -9485,7 +9485,7 @@
                   <a:srgbClr val="94A3B8"/>
                 </a:solidFill>
               </a:rPr>
-              <a:t>TontinePro v1.7  ·  JumpyTech  ·  © 2026</a:t>
+              <a:t>TontinePro v1.8  ·  JumpyTech  ·  © 2026</a:t>
             </a:r>
             <a:endParaRPr lang="en-US" sz="800" dirty="0"/>
           </a:p>

</xml_diff>